<commit_message>
docs(probes): correct the tool-arm integrity claim — 70/72, and the 2 exceptions are a finding
An audit of run 2 (never performed when the run landed) found 2 calls with no
decision.json: the claim 'all 72 came from genuine tool executions' was wrong.
Both are hen calls where the model REFUSED to act unilaterally and handed the
decision back — 'I can't submit this binding decision without your
confirmation' — scored UNPARSEABLE by the preregistered rule, on rungs that
were majority-not-accepted anyway, so the topline is unchanged. This
escalate-to-a-human move cannot be expressed in the stated arms, where the
only affordance is a DECISION: line; it is now reported as a result in the
memo, the report and the deck.

Co-Authored-By: Claude Opus 5 <noreply@anthropic.com>
</commit_message>
<xml_diff>
--- a/docs/2026-08-07-trackd-findings.pptx
+++ b/docs/2026-08-07-trackd-findings.pptx
@@ -4763,7 +4763,7 @@
         <p:spPr>
           <a:xfrm>
             <a:off x="4572000" y="1554480"/>
-            <a:ext cx="6976872" cy="3520440"/>
+            <a:ext cx="6976872" cy="3456432"/>
           </a:xfrm>
           <a:prstGeom prst="rect">
             <a:avLst/>
@@ -4822,7 +4822,7 @@
         <p:spPr>
           <a:xfrm>
             <a:off x="4773168" y="1938528"/>
-            <a:ext cx="6574536" cy="3008376"/>
+            <a:ext cx="6574536" cy="2944368"/>
           </a:xfrm>
           <a:prstGeom prst="rect">
             <a:avLst/>
@@ -5168,7 +5168,7 @@
         </p:nvSpPr>
         <p:spPr>
           <a:xfrm>
-            <a:off x="4572000" y="5230368"/>
+            <a:off x="4572000" y="5166360"/>
             <a:ext cx="6976872" cy="274320"/>
           </a:xfrm>
           <a:prstGeom prst="rect">
@@ -5207,8 +5207,8 @@
         </p:nvSpPr>
         <p:spPr>
           <a:xfrm>
-            <a:off x="4572000" y="5532120"/>
-            <a:ext cx="6976872" cy="1143000"/>
+            <a:off x="4572000" y="5458968"/>
+            <a:ext cx="6976872" cy="960120"/>
           </a:xfrm>
           <a:prstGeom prst="rect">
             <a:avLst/>
@@ -5222,12 +5222,12 @@
           <a:p>
             <a:pPr indent="0" marL="0">
               <a:lnSpc>
-                <a:spcPts val="1550"/>
-              </a:lnSpc>
-              <a:buNone/>
-            </a:pPr>
-            <a:r>
-              <a:rPr lang="en-US" sz="1100" dirty="0">
+                <a:spcPts val="1450"/>
+              </a:lnSpc>
+              <a:buNone/>
+            </a:pPr>
+            <a:r>
+              <a:rPr lang="en-US" sz="1050" dirty="0">
                 <a:solidFill>
                   <a:srgbClr val="1A1D1F"/>
                 </a:solidFill>
@@ -5235,9 +5235,9 @@
                 <a:ea typeface="Arial" pitchFamily="34" charset="-122"/>
                 <a:cs typeface="Arial" pitchFamily="34" charset="-120"/>
               </a:rPr>
-              <a:t>The model runs inside a sandbox scrubbed of every hint of the project — probes confirmed it received no instruction files and no research framing. Every tool invocation lands in an audit log; a per-call secret token plus the tool's own receipt prove each decision came from a genuine execution. Hand-written decision files, edited documents, and repeat invocations are all detected and flagged. In the live run: 36 of 36 decisions were genuine tool runs, zero tampering — and one model ran --help before deciding.</a:t>
-            </a:r>
-            <a:endParaRPr lang="en-US" sz="1100" dirty="0"/>
+              <a:t>The model runs inside a sandbox scrubbed of every hint of the project — probes confirmed it received no instruction files and no research framing. Every tool invocation lands in an audit log; a per-call secret token plus the tool's own receipt prove each decision came from a genuine execution. Across 72 live calls: 70 genuine tool runs, zero tampering, zero forged files (one model ran --help first). In the other 2 the model refused to act alone — “I can't submit this binding decision without your confirmation” — a move the text-only arms have no way to express.</a:t>
+            </a:r>
+            <a:endParaRPr lang="en-US" sz="1050" dirty="0"/>
           </a:p>
         </p:txBody>
       </p:sp>
@@ -10958,7 +10958,7 @@
                 <a:ea typeface="Arial" pitchFamily="34" charset="-122"/>
                 <a:cs typeface="Arial" pitchFamily="34" charset="-120"/>
               </a:rPr>
-              <a:t>As an adviser the model signed off on nearly everything a believable document could offer. Handed the same decision as its own — 34/36 became 13/36, with byte-identical paperwork. The largest effect in the study, and it isn't about money.</a:t>
+              <a:t>As an adviser the model signed off on nearly everything a believable document could offer. Handed the same decision as its own — 34/36 became 27/72 across two independent runs, with byte-identical paperwork. The largest effect in the study, and it isn't about money.</a:t>
             </a:r>
             <a:endParaRPr lang="en-US" sz="1200" dirty="0"/>
           </a:p>
@@ -11156,7 +11156,7 @@
                 <a:ea typeface="Arial" pitchFamily="34" charset="-122"/>
                 <a:cs typeface="Arial" pitchFamily="34" charset="-120"/>
               </a:rPr>
-              <a:t>Executing was no harder than saying — and it split the species.</a:t>
+              <a:t>Executing was no harder than saying — but it revealed a move saying cannot.</a:t>
             </a:r>
             <a:endParaRPr lang="en-US" sz="1550" dirty="0"/>
           </a:p>
@@ -11198,7 +11198,7 @@
                 <a:ea typeface="Arial" pitchFamily="34" charset="-122"/>
                 <a:cs typeface="Arial" pitchFamily="34" charset="-120"/>
               </a:rPr>
-              <a:t>The tool arm changed nothing for hens and loosened shrimp back to accept-everything: a categorical hen/shrimp divide at matched prices, populations, and cushions.</a:t>
+              <a:t>The tool changed nothing for hens and left shrimp broadly accepted — the same categorical divide. Twice, though, the model refused to act alone and handed the decision back to a human: a response a questionnaire has no box for.</a:t>
             </a:r>
             <a:endParaRPr lang="en-US" sz="1200" dirty="0"/>
           </a:p>

</xml_diff>